<commit_message>
docs(ventas): material comercial — estrategia, catálogo, guiones y decks
Sección nueva 09-Ventas en la KB (estrategia comercial por segmento, catálogo
de módulos vendibles con el estado real de cada feature, guiones para
inmobiliarias con y sin CRM, contenido de los dos decks) más su entrada en el
MOC. Se actualizan los .pptx/.docx entregables de ventas-storytelling/.

Co-Authored-By: Claude Opus 5 (1M context) <noreply@anthropic.com>
Claude-Session: https://claude.ai/code/session_01Wjx4mz3WsiBcVcYUXhYbTg
</commit_message>
<xml_diff>
--- a/ventas-storytelling/VendePro_Deck_Segmento1.pptx
+++ b/ventas-storytelling/VendePro_Deck_Segmento1.pptx
@@ -17,9 +17,10 @@
     <p:sldId id="265" r:id="rId11"/>
     <p:sldId id="266" r:id="rId12"/>
     <p:sldId id="267" r:id="rId13"/>
+    <p:sldId id="268" r:id="rId14"/>
   </p:sldIdLst>
   <p:notesMasterIdLst>
-    <p:notesMasterId r:id="rId14"/>
+    <p:notesMasterId r:id="rId15"/>
   </p:notesMasterIdLst>
   <p:sldSz cx="12192000" cy="6858000"/>
   <p:notesSz cx="6858000" cy="12192000"/>
@@ -801,6 +802,94 @@
             <a:fld id="{F7021451-1387-4CA6-816F-3879F97B5CBC}" type="slidenum">
               <a:rPr lang="en-US"/>
               <a:t>12</a:t>
+            </a:fld>
+            <a:endParaRPr lang="en-US"/>
+          </a:p>
+        </p:txBody>
+      </p:sp>
+    </p:spTree>
+    <p:extLst>
+      <p:ext uri="{BB962C8B-B14F-4D97-AF65-F5344CB8AC3E}">
+        <p14:creationId xmlns:p14="http://schemas.microsoft.com/office/powerpoint/2010/main" val="1024086991"/>
+      </p:ext>
+    </p:extLst>
+  </p:cSld>
+  <p:clrMapOvr>
+    <a:masterClrMapping/>
+  </p:clrMapOvr>
+</p:notes>
+</file>
+
+<file path=ppt/notesSlides/notesSlide13.xml><?xml version="1.0" encoding="utf-8"?>
+<p:notes xmlns:a="http://schemas.openxmlformats.org/drawingml/2006/main" xmlns:r="http://schemas.openxmlformats.org/officeDocument/2006/relationships" xmlns:p="http://schemas.openxmlformats.org/presentationml/2006/main">
+  <p:cSld>
+    <p:spTree>
+      <p:nvGrpSpPr>
+        <p:cNvPr id="1" name=""/>
+        <p:cNvGrpSpPr/>
+        <p:nvPr/>
+      </p:nvGrpSpPr>
+      <p:grpSpPr>
+        <a:xfrm>
+          <a:off x="0" y="0"/>
+          <a:ext cx="0" cy="0"/>
+          <a:chOff x="0" y="0"/>
+          <a:chExt cx="0" cy="0"/>
+        </a:xfrm>
+      </p:grpSpPr>
+      <p:sp>
+        <p:nvSpPr>
+          <p:cNvPr id="2" name="Slide Image Placeholder 1"/>
+          <p:cNvSpPr>
+            <a:spLocks noGrp="1" noRot="1" noChangeAspect="1"/>
+          </p:cNvSpPr>
+          <p:nvPr>
+            <p:ph type="sldImg"/>
+          </p:nvPr>
+        </p:nvSpPr>
+        <p:spPr/>
+      </p:sp>
+      <p:sp>
+        <p:nvSpPr>
+          <p:cNvPr id="3" name="Notes Placeholder 2"/>
+          <p:cNvSpPr>
+            <a:spLocks noGrp="1"/>
+          </p:cNvSpPr>
+          <p:nvPr>
+            <p:ph type="body" idx="1"/>
+          </p:nvPr>
+        </p:nvSpPr>
+        <p:spPr/>
+        <p:txBody>
+          <a:bodyPr/>
+          <a:lstStyle/>
+          <a:p>
+            <a:r>
+              <a:rPr lang="en-US" dirty="0"/>
+              <a:t/>
+            </a:r>
+            <a:endParaRPr lang="en-US" dirty="0"/>
+          </a:p>
+        </p:txBody>
+      </p:sp>
+      <p:sp>
+        <p:nvSpPr>
+          <p:cNvPr id="4" name="Slide Number Placeholder 3"/>
+          <p:cNvSpPr>
+            <a:spLocks noGrp="1"/>
+          </p:cNvSpPr>
+          <p:nvPr>
+            <p:ph type="sldNum" sz="quarter" idx="10"/>
+          </p:nvPr>
+        </p:nvSpPr>
+        <p:spPr/>
+        <p:txBody>
+          <a:bodyPr/>
+          <a:lstStyle/>
+          <a:p>
+            <a:fld id="{F7021451-1387-4CA6-816F-3879F97B5CBC}" type="slidenum">
+              <a:rPr lang="en-US"/>
+              <a:t>13</a:t>
             </a:fld>
             <a:endParaRPr lang="en-US"/>
           </a:p>
@@ -2021,7 +2110,7 @@
                 <a:ea typeface="Poppins Medium" pitchFamily="34" charset="-122"/>
                 <a:cs typeface="Poppins Medium" pitchFamily="34" charset="-120"/>
               </a:rPr>
-              <a:t>01 / 12</a:t>
+              <a:t>01 / 13</a:t>
             </a:r>
             <a:endParaRPr lang="en-US" sz="950" dirty="0"/>
           </a:p>
@@ -2526,7 +2615,7 @@
                 <a:ea typeface="Poppins Medium" pitchFamily="34" charset="-122"/>
                 <a:cs typeface="Poppins Medium" pitchFamily="34" charset="-120"/>
               </a:rPr>
-              <a:t>10 / 12</a:t>
+              <a:t>10 / 13</a:t>
             </a:r>
             <a:endParaRPr lang="en-US" sz="950" dirty="0"/>
           </a:p>
@@ -2597,7 +2686,7 @@
         <p:spPr>
           <a:xfrm>
             <a:off x="896112" y="512064"/>
-            <a:ext cx="10369296" cy="1051560"/>
+            <a:ext cx="10643616" cy="1051560"/>
           </a:xfrm>
           <a:prstGeom prst="rect">
             <a:avLst/>
@@ -2616,7 +2705,7 @@
               <a:buNone/>
             </a:pPr>
             <a:r>
-              <a:rPr lang="en-US" sz="2800" b="1" dirty="0">
+              <a:rPr lang="en-US" sz="2400" b="1" dirty="0">
                 <a:solidFill>
                   <a:srgbClr val="27272A"/>
                 </a:solidFill>
@@ -2624,9 +2713,9 @@
                 <a:ea typeface="Poppins" pitchFamily="34" charset="-122"/>
                 <a:cs typeface="Poppins" pitchFamily="34" charset="-120"/>
               </a:rPr>
-              <a:t>Sin tarjeta. Sin límite de tiempo. Setup en 2 minutos.</a:t>
-            </a:r>
-            <a:endParaRPr lang="en-US" sz="2800" dirty="0"/>
+              <a:t>Así se construye VendéPro: módulo por módulo, según lo que pidan los clientes</a:t>
+            </a:r>
+            <a:endParaRPr lang="en-US" sz="2400" dirty="0"/>
           </a:p>
         </p:txBody>
       </p:sp>
@@ -2638,34 +2727,37 @@
         </p:nvSpPr>
         <p:spPr>
           <a:xfrm>
-            <a:off x="658368" y="6437376"/>
-            <a:ext cx="1828800" cy="274320"/>
-          </a:xfrm>
-          <a:prstGeom prst="rect">
-            <a:avLst/>
-          </a:prstGeom>
-          <a:noFill/>
-          <a:ln/>
-        </p:spPr>
-        <p:txBody>
-          <a:bodyPr wrap="square" lIns="0" tIns="0" rIns="0" bIns="0" rtlCol="0" anchor="ctr"/>
-          <a:lstStyle/>
-          <a:p>
-            <a:pPr algn="l" indent="0" marL="0">
-              <a:buNone/>
-            </a:pPr>
-            <a:r>
-              <a:rPr lang="en-US" sz="950" spc="100" kern="0" dirty="0">
-                <a:solidFill>
-                  <a:srgbClr val="A1A1AA"/>
+            <a:off x="896112" y="1536192"/>
+            <a:ext cx="10332720" cy="502920"/>
+          </a:xfrm>
+          <a:prstGeom prst="rect">
+            <a:avLst/>
+          </a:prstGeom>
+          <a:noFill/>
+          <a:ln/>
+        </p:spPr>
+        <p:txBody>
+          <a:bodyPr wrap="square" lIns="0" tIns="0" rIns="0" bIns="0" rtlCol="0" anchor="t"/>
+          <a:lstStyle/>
+          <a:p>
+            <a:pPr indent="0" marL="0">
+              <a:lnSpc>
+                <a:spcPct val="125000"/>
+              </a:lnSpc>
+              <a:buNone/>
+            </a:pPr>
+            <a:r>
+              <a:rPr lang="en-US" sz="1400" dirty="0">
+                <a:solidFill>
+                  <a:srgbClr val="52525B"/>
                 </a:solidFill>
                 <a:latin typeface="Poppins Medium" pitchFamily="34" charset="0"/>
                 <a:ea typeface="Poppins Medium" pitchFamily="34" charset="-122"/>
                 <a:cs typeface="Poppins Medium" pitchFamily="34" charset="-120"/>
               </a:rPr>
-              <a:t>VendéPro</a:t>
-            </a:r>
-            <a:endParaRPr lang="en-US" sz="950" dirty="0"/>
+              <a:t>Cada módulo se construye cuando los clientes lo piden — por eso tu opinión hoy importa.</a:t>
+            </a:r>
+            <a:endParaRPr lang="en-US" sz="1400" dirty="0"/>
           </a:p>
         </p:txBody>
       </p:sp>
@@ -2677,8 +2769,8 @@
         </p:nvSpPr>
         <p:spPr>
           <a:xfrm>
-            <a:off x="10436047" y="6437376"/>
-            <a:ext cx="1097280" cy="274320"/>
+            <a:off x="658368" y="6437376"/>
+            <a:ext cx="1828800" cy="274320"/>
           </a:xfrm>
           <a:prstGeom prst="rect">
             <a:avLst/>
@@ -2690,11 +2782,11 @@
           <a:bodyPr wrap="square" lIns="0" tIns="0" rIns="0" bIns="0" rtlCol="0" anchor="ctr"/>
           <a:lstStyle/>
           <a:p>
-            <a:pPr algn="r" indent="0" marL="0">
-              <a:buNone/>
-            </a:pPr>
-            <a:r>
-              <a:rPr lang="en-US" sz="950" dirty="0">
+            <a:pPr algn="l" indent="0" marL="0">
+              <a:buNone/>
+            </a:pPr>
+            <a:r>
+              <a:rPr lang="en-US" sz="950" spc="100" kern="0" dirty="0">
                 <a:solidFill>
                   <a:srgbClr val="A1A1AA"/>
                 </a:solidFill>
@@ -2702,7 +2794,7 @@
                 <a:ea typeface="Poppins Medium" pitchFamily="34" charset="-122"/>
                 <a:cs typeface="Poppins Medium" pitchFamily="34" charset="-120"/>
               </a:rPr>
-              <a:t>11 / 12</a:t>
+              <a:t>VendéPro</a:t>
             </a:r>
             <a:endParaRPr lang="en-US" sz="950" dirty="0"/>
           </a:p>
@@ -2710,18 +2802,57 @@
       </p:sp>
       <p:sp>
         <p:nvSpPr>
-          <p:cNvPr id="6" name="Shape 3"/>
+          <p:cNvPr id="6" name="Text 3"/>
+          <p:cNvSpPr txBox="1"/>
+          <p:nvPr/>
+        </p:nvSpPr>
+        <p:spPr>
+          <a:xfrm>
+            <a:off x="10436047" y="6437376"/>
+            <a:ext cx="1097280" cy="274320"/>
+          </a:xfrm>
+          <a:prstGeom prst="rect">
+            <a:avLst/>
+          </a:prstGeom>
+          <a:noFill/>
+          <a:ln/>
+        </p:spPr>
+        <p:txBody>
+          <a:bodyPr wrap="square" lIns="0" tIns="0" rIns="0" bIns="0" rtlCol="0" anchor="ctr"/>
+          <a:lstStyle/>
+          <a:p>
+            <a:pPr algn="r" indent="0" marL="0">
+              <a:buNone/>
+            </a:pPr>
+            <a:r>
+              <a:rPr lang="en-US" sz="950" dirty="0">
+                <a:solidFill>
+                  <a:srgbClr val="A1A1AA"/>
+                </a:solidFill>
+                <a:latin typeface="Poppins Medium" pitchFamily="34" charset="0"/>
+                <a:ea typeface="Poppins Medium" pitchFamily="34" charset="-122"/>
+                <a:cs typeface="Poppins Medium" pitchFamily="34" charset="-120"/>
+              </a:rPr>
+              <a:t>11 / 13</a:t>
+            </a:r>
+            <a:endParaRPr lang="en-US" sz="950" dirty="0"/>
+          </a:p>
+        </p:txBody>
+      </p:sp>
+      <p:sp>
+        <p:nvSpPr>
+          <p:cNvPr id="7" name="Shape 4"/>
           <p:cNvSpPr/>
           <p:nvPr/>
         </p:nvSpPr>
         <p:spPr>
           <a:xfrm>
-            <a:off x="658368" y="2331720"/>
-            <a:ext cx="3411626" cy="1371600"/>
+            <a:off x="658368" y="2286000"/>
+            <a:ext cx="3289706" cy="3840480"/>
           </a:xfrm>
           <a:prstGeom prst="roundRect">
             <a:avLst>
-              <a:gd name="adj" fmla="val 12000"/>
+              <a:gd name="adj" fmla="val 5003"/>
             </a:avLst>
           </a:prstGeom>
           <a:solidFill>
@@ -2739,7 +2870,7 @@
       </p:sp>
       <p:pic>
         <p:nvPicPr>
-          <p:cNvPr id="7" name="Image 1" descr="/tmp/claude-0/-home-claude/34a532c3-29f6-5221-b4ba-d8e6b49c9601/scratchpad/vendepro/assets/icon_check_grad.png">    </p:cNvPr>
+          <p:cNvPr id="8" name="Image 1" descr="/tmp/claude-0/-home-claude/34a532c3-29f6-5221-b4ba-d8e6b49c9601/scratchpad/vendepro/assets/grad_num_circle.png">    </p:cNvPr>
           <p:cNvPicPr>
             <a:picLocks noChangeAspect="1"/>
           </p:cNvPicPr>
@@ -2753,8 +2884,8 @@
         </p:blipFill>
         <p:spPr>
           <a:xfrm>
-            <a:off x="2135581" y="2624328"/>
-            <a:ext cx="457200" cy="457200"/>
+            <a:off x="932688" y="2560320"/>
+            <a:ext cx="548640" cy="548640"/>
           </a:xfrm>
           <a:prstGeom prst="rect">
             <a:avLst/>
@@ -2763,57 +2894,363 @@
       </p:pic>
       <p:sp>
         <p:nvSpPr>
-          <p:cNvPr id="8" name="Text 4"/>
-          <p:cNvSpPr txBox="1"/>
-          <p:nvPr/>
-        </p:nvSpPr>
-        <p:spPr>
-          <a:xfrm>
-            <a:off x="841248" y="3200400"/>
-            <a:ext cx="3045866" cy="457200"/>
-          </a:xfrm>
-          <a:prstGeom prst="rect">
-            <a:avLst/>
-          </a:prstGeom>
-          <a:noFill/>
-          <a:ln/>
-        </p:spPr>
-        <p:txBody>
-          <a:bodyPr wrap="square" lIns="0" tIns="0" rIns="0" bIns="0" rtlCol="0" anchor="t"/>
+          <p:cNvPr id="9" name="Text 5"/>
+          <p:cNvSpPr txBox="1"/>
+          <p:nvPr/>
+        </p:nvSpPr>
+        <p:spPr>
+          <a:xfrm>
+            <a:off x="932688" y="2560320"/>
+            <a:ext cx="548640" cy="548640"/>
+          </a:xfrm>
+          <a:prstGeom prst="rect">
+            <a:avLst/>
+          </a:prstGeom>
+          <a:noFill/>
+          <a:ln/>
+        </p:spPr>
+        <p:txBody>
+          <a:bodyPr wrap="square" lIns="0" tIns="0" rIns="0" bIns="0" rtlCol="0" anchor="ctr"/>
           <a:lstStyle/>
           <a:p>
             <a:pPr algn="ctr" indent="0" marL="0">
               <a:buNone/>
             </a:pPr>
             <a:r>
-              <a:rPr lang="en-US" sz="1500" b="1" dirty="0">
-                <a:solidFill>
-                  <a:srgbClr val="27272A"/>
+              <a:rPr lang="en-US" sz="2000" b="1" dirty="0">
+                <a:solidFill>
+                  <a:srgbClr val="FFFFFF"/>
                 </a:solidFill>
                 <a:latin typeface="Poppins" pitchFamily="34" charset="0"/>
                 <a:ea typeface="Poppins" pitchFamily="34" charset="-122"/>
                 <a:cs typeface="Poppins" pitchFamily="34" charset="-120"/>
               </a:rPr>
-              <a:t>Sin tarjeta</a:t>
-            </a:r>
-            <a:endParaRPr lang="en-US" sz="1500" dirty="0"/>
-          </a:p>
-        </p:txBody>
-      </p:sp>
-      <p:sp>
-        <p:nvSpPr>
-          <p:cNvPr id="9" name="Shape 5"/>
+              <a:t>A</a:t>
+            </a:r>
+            <a:endParaRPr lang="en-US" sz="2000" dirty="0"/>
+          </a:p>
+        </p:txBody>
+      </p:sp>
+      <p:sp>
+        <p:nvSpPr>
+          <p:cNvPr id="10" name="Text 6"/>
+          <p:cNvSpPr txBox="1"/>
+          <p:nvPr/>
+        </p:nvSpPr>
+        <p:spPr>
+          <a:xfrm>
+            <a:off x="932688" y="3310128"/>
+            <a:ext cx="2741066" cy="548640"/>
+          </a:xfrm>
+          <a:prstGeom prst="rect">
+            <a:avLst/>
+          </a:prstGeom>
+          <a:noFill/>
+          <a:ln/>
+        </p:spPr>
+        <p:txBody>
+          <a:bodyPr wrap="square" lIns="0" tIns="0" rIns="0" bIns="0" rtlCol="0" anchor="t"/>
+          <a:lstStyle/>
+          <a:p>
+            <a:pPr indent="0" marL="0">
+              <a:lnSpc>
+                <a:spcPct val="115000"/>
+              </a:lnSpc>
+              <a:buNone/>
+            </a:pPr>
+            <a:r>
+              <a:rPr lang="en-US" sz="1650" b="1" dirty="0">
+                <a:solidFill>
+                  <a:srgbClr val="27272A"/>
+                </a:solidFill>
+                <a:latin typeface="Poppins" pitchFamily="34" charset="0"/>
+                <a:ea typeface="Poppins" pitchFamily="34" charset="-122"/>
+                <a:cs typeface="Poppins" pitchFamily="34" charset="-120"/>
+              </a:rPr>
+              <a:t>Marketing con ROI real</a:t>
+            </a:r>
+            <a:endParaRPr lang="en-US" sz="1650" dirty="0"/>
+          </a:p>
+        </p:txBody>
+      </p:sp>
+      <p:sp>
+        <p:nvSpPr>
+          <p:cNvPr id="11" name="Text 7"/>
+          <p:cNvSpPr txBox="1"/>
+          <p:nvPr/>
+        </p:nvSpPr>
+        <p:spPr>
+          <a:xfrm>
+            <a:off x="932688" y="3913632"/>
+            <a:ext cx="2741066" cy="320040"/>
+          </a:xfrm>
+          <a:prstGeom prst="rect">
+            <a:avLst/>
+          </a:prstGeom>
+          <a:noFill/>
+          <a:ln/>
+        </p:spPr>
+        <p:txBody>
+          <a:bodyPr wrap="square" lIns="0" tIns="0" rIns="0" bIns="0" rtlCol="0" anchor="t"/>
+          <a:lstStyle/>
+          <a:p>
+            <a:pPr indent="0" marL="0">
+              <a:buNone/>
+            </a:pPr>
+            <a:r>
+              <a:rPr lang="en-US" sz="1150" i="1" dirty="0">
+                <a:solidFill>
+                  <a:srgbClr val="71717A"/>
+                </a:solidFill>
+                <a:latin typeface="Poppins Medium" pitchFamily="34" charset="0"/>
+                <a:ea typeface="Poppins Medium" pitchFamily="34" charset="-122"/>
+                <a:cs typeface="Poppins Medium" pitchFamily="34" charset="-120"/>
+              </a:rPr>
+              <a:t>(el que se cobra)</a:t>
+            </a:r>
+            <a:endParaRPr lang="en-US" sz="1150" dirty="0"/>
+          </a:p>
+        </p:txBody>
+      </p:sp>
+      <p:sp>
+        <p:nvSpPr>
+          <p:cNvPr id="12" name="Shape 8"/>
           <p:cNvSpPr/>
           <p:nvPr/>
         </p:nvSpPr>
         <p:spPr>
           <a:xfrm>
-            <a:off x="4390034" y="2331720"/>
-            <a:ext cx="3411626" cy="1371600"/>
+            <a:off x="932688" y="4453128"/>
+            <a:ext cx="82296" cy="82296"/>
+          </a:xfrm>
+          <a:prstGeom prst="ellipse">
+            <a:avLst/>
+          </a:prstGeom>
+          <a:solidFill>
+            <a:srgbClr val="FF007C"/>
+          </a:solidFill>
+          <a:ln/>
+        </p:spPr>
+      </p:sp>
+      <p:sp>
+        <p:nvSpPr>
+          <p:cNvPr id="13" name="Text 9"/>
+          <p:cNvSpPr txBox="1"/>
+          <p:nvPr/>
+        </p:nvSpPr>
+        <p:spPr>
+          <a:xfrm>
+            <a:off x="1133856" y="4325112"/>
+            <a:ext cx="2539898" cy="457200"/>
+          </a:xfrm>
+          <a:prstGeom prst="rect">
+            <a:avLst/>
+          </a:prstGeom>
+          <a:noFill/>
+          <a:ln/>
+        </p:spPr>
+        <p:txBody>
+          <a:bodyPr wrap="square" lIns="0" tIns="0" rIns="0" bIns="0" rtlCol="0" anchor="t"/>
+          <a:lstStyle/>
+          <a:p>
+            <a:pPr indent="0" marL="0">
+              <a:lnSpc>
+                <a:spcPct val="120000"/>
+              </a:lnSpc>
+              <a:buNone/>
+            </a:pPr>
+            <a:r>
+              <a:rPr lang="en-US" sz="1250" dirty="0">
+                <a:solidFill>
+                  <a:srgbClr val="27272A"/>
+                </a:solidFill>
+                <a:latin typeface="Poppins" pitchFamily="34" charset="0"/>
+                <a:ea typeface="Poppins" pitchFamily="34" charset="-122"/>
+                <a:cs typeface="Poppins" pitchFamily="34" charset="-120"/>
+              </a:rPr>
+              <a:t>Medir campañas</a:t>
+            </a:r>
+            <a:endParaRPr lang="en-US" sz="1250" dirty="0"/>
+          </a:p>
+        </p:txBody>
+      </p:sp>
+      <p:sp>
+        <p:nvSpPr>
+          <p:cNvPr id="14" name="Shape 10"/>
+          <p:cNvSpPr/>
+          <p:nvPr/>
+        </p:nvSpPr>
+        <p:spPr>
+          <a:xfrm>
+            <a:off x="932688" y="4910328"/>
+            <a:ext cx="82296" cy="82296"/>
+          </a:xfrm>
+          <a:prstGeom prst="ellipse">
+            <a:avLst/>
+          </a:prstGeom>
+          <a:solidFill>
+            <a:srgbClr val="FF007C"/>
+          </a:solidFill>
+          <a:ln/>
+        </p:spPr>
+      </p:sp>
+      <p:sp>
+        <p:nvSpPr>
+          <p:cNvPr id="15" name="Text 11"/>
+          <p:cNvSpPr txBox="1"/>
+          <p:nvPr/>
+        </p:nvSpPr>
+        <p:spPr>
+          <a:xfrm>
+            <a:off x="1133856" y="4782312"/>
+            <a:ext cx="2539898" cy="457200"/>
+          </a:xfrm>
+          <a:prstGeom prst="rect">
+            <a:avLst/>
+          </a:prstGeom>
+          <a:noFill/>
+          <a:ln/>
+        </p:spPr>
+        <p:txBody>
+          <a:bodyPr wrap="square" lIns="0" tIns="0" rIns="0" bIns="0" rtlCol="0" anchor="t"/>
+          <a:lstStyle/>
+          <a:p>
+            <a:pPr indent="0" marL="0">
+              <a:lnSpc>
+                <a:spcPct val="120000"/>
+              </a:lnSpc>
+              <a:buNone/>
+            </a:pPr>
+            <a:r>
+              <a:rPr lang="en-US" sz="1250" dirty="0">
+                <a:solidFill>
+                  <a:srgbClr val="27272A"/>
+                </a:solidFill>
+                <a:latin typeface="Poppins" pitchFamily="34" charset="0"/>
+                <a:ea typeface="Poppins" pitchFamily="34" charset="-122"/>
+                <a:cs typeface="Poppins" pitchFamily="34" charset="-120"/>
+              </a:rPr>
+              <a:t>Saber qué convierte</a:t>
+            </a:r>
+            <a:endParaRPr lang="en-US" sz="1250" dirty="0"/>
+          </a:p>
+        </p:txBody>
+      </p:sp>
+      <p:sp>
+        <p:nvSpPr>
+          <p:cNvPr id="16" name="Shape 12"/>
+          <p:cNvSpPr/>
+          <p:nvPr/>
+        </p:nvSpPr>
+        <p:spPr>
+          <a:xfrm>
+            <a:off x="932688" y="5367528"/>
+            <a:ext cx="82296" cy="82296"/>
+          </a:xfrm>
+          <a:prstGeom prst="ellipse">
+            <a:avLst/>
+          </a:prstGeom>
+          <a:solidFill>
+            <a:srgbClr val="FF007C"/>
+          </a:solidFill>
+          <a:ln/>
+        </p:spPr>
+      </p:sp>
+      <p:sp>
+        <p:nvSpPr>
+          <p:cNvPr id="17" name="Text 13"/>
+          <p:cNvSpPr txBox="1"/>
+          <p:nvPr/>
+        </p:nvSpPr>
+        <p:spPr>
+          <a:xfrm>
+            <a:off x="1133856" y="5239512"/>
+            <a:ext cx="2539898" cy="457200"/>
+          </a:xfrm>
+          <a:prstGeom prst="rect">
+            <a:avLst/>
+          </a:prstGeom>
+          <a:noFill/>
+          <a:ln/>
+        </p:spPr>
+        <p:txBody>
+          <a:bodyPr wrap="square" lIns="0" tIns="0" rIns="0" bIns="0" rtlCol="0" anchor="t"/>
+          <a:lstStyle/>
+          <a:p>
+            <a:pPr indent="0" marL="0">
+              <a:lnSpc>
+                <a:spcPct val="120000"/>
+              </a:lnSpc>
+              <a:buNone/>
+            </a:pPr>
+            <a:r>
+              <a:rPr lang="en-US" sz="1250" dirty="0">
+                <a:solidFill>
+                  <a:srgbClr val="27272A"/>
+                </a:solidFill>
+                <a:latin typeface="Poppins" pitchFamily="34" charset="0"/>
+                <a:ea typeface="Poppins" pitchFamily="34" charset="-122"/>
+                <a:cs typeface="Poppins" pitchFamily="34" charset="-120"/>
+              </a:rPr>
+              <a:t>Red de cierres reales</a:t>
+            </a:r>
+            <a:endParaRPr lang="en-US" sz="1250" dirty="0"/>
+          </a:p>
+        </p:txBody>
+      </p:sp>
+      <p:sp>
+        <p:nvSpPr>
+          <p:cNvPr id="18" name="Text 14"/>
+          <p:cNvSpPr txBox="1"/>
+          <p:nvPr/>
+        </p:nvSpPr>
+        <p:spPr>
+          <a:xfrm>
+            <a:off x="3948074" y="2542032"/>
+            <a:ext cx="502920" cy="566928"/>
+          </a:xfrm>
+          <a:prstGeom prst="rect">
+            <a:avLst/>
+          </a:prstGeom>
+          <a:noFill/>
+          <a:ln/>
+        </p:spPr>
+        <p:txBody>
+          <a:bodyPr wrap="square" lIns="0" tIns="0" rIns="0" bIns="0" rtlCol="0" anchor="ctr"/>
+          <a:lstStyle/>
+          <a:p>
+            <a:pPr algn="ctr" indent="0" marL="0">
+              <a:buNone/>
+            </a:pPr>
+            <a:r>
+              <a:rPr lang="en-US" sz="2200" b="1" dirty="0">
+                <a:solidFill>
+                  <a:srgbClr val="FF007C"/>
+                </a:solidFill>
+                <a:latin typeface="Poppins" pitchFamily="34" charset="0"/>
+                <a:ea typeface="Poppins" pitchFamily="34" charset="-122"/>
+                <a:cs typeface="Poppins" pitchFamily="34" charset="-120"/>
+              </a:rPr>
+              <a:t>→</a:t>
+            </a:r>
+            <a:endParaRPr lang="en-US" sz="2200" dirty="0"/>
+          </a:p>
+        </p:txBody>
+      </p:sp>
+      <p:sp>
+        <p:nvSpPr>
+          <p:cNvPr id="19" name="Shape 15"/>
+          <p:cNvSpPr/>
+          <p:nvPr/>
+        </p:nvSpPr>
+        <p:spPr>
+          <a:xfrm>
+            <a:off x="4450994" y="2286000"/>
+            <a:ext cx="3289706" cy="3840480"/>
           </a:xfrm>
           <a:prstGeom prst="roundRect">
             <a:avLst>
-              <a:gd name="adj" fmla="val 12000"/>
+              <a:gd name="adj" fmla="val 5003"/>
             </a:avLst>
           </a:prstGeom>
           <a:solidFill>
@@ -2831,7 +3268,7 @@
       </p:sp>
       <p:pic>
         <p:nvPicPr>
-          <p:cNvPr id="10" name="Image 2" descr="/tmp/claude-0/-home-claude/34a532c3-29f6-5221-b4ba-d8e6b49c9601/scratchpad/vendepro/assets/icon_check_grad.png">    </p:cNvPr>
+          <p:cNvPr id="20" name="Image 2" descr="/tmp/claude-0/-home-claude/34a532c3-29f6-5221-b4ba-d8e6b49c9601/scratchpad/vendepro/assets/grad_num_circle.png">    </p:cNvPr>
           <p:cNvPicPr>
             <a:picLocks noChangeAspect="1"/>
           </p:cNvPicPr>
@@ -2845,8 +3282,8 @@
         </p:blipFill>
         <p:spPr>
           <a:xfrm>
-            <a:off x="5867248" y="2624328"/>
-            <a:ext cx="457200" cy="457200"/>
+            <a:off x="4725314" y="2560320"/>
+            <a:ext cx="548640" cy="548640"/>
           </a:xfrm>
           <a:prstGeom prst="rect">
             <a:avLst/>
@@ -2855,57 +3292,324 @@
       </p:pic>
       <p:sp>
         <p:nvSpPr>
-          <p:cNvPr id="11" name="Text 6"/>
-          <p:cNvSpPr txBox="1"/>
-          <p:nvPr/>
-        </p:nvSpPr>
-        <p:spPr>
-          <a:xfrm>
-            <a:off x="4572914" y="3200400"/>
-            <a:ext cx="3045866" cy="457200"/>
-          </a:xfrm>
-          <a:prstGeom prst="rect">
-            <a:avLst/>
-          </a:prstGeom>
-          <a:noFill/>
-          <a:ln/>
-        </p:spPr>
-        <p:txBody>
-          <a:bodyPr wrap="square" lIns="0" tIns="0" rIns="0" bIns="0" rtlCol="0" anchor="t"/>
+          <p:cNvPr id="21" name="Text 16"/>
+          <p:cNvSpPr txBox="1"/>
+          <p:nvPr/>
+        </p:nvSpPr>
+        <p:spPr>
+          <a:xfrm>
+            <a:off x="4725314" y="2560320"/>
+            <a:ext cx="548640" cy="548640"/>
+          </a:xfrm>
+          <a:prstGeom prst="rect">
+            <a:avLst/>
+          </a:prstGeom>
+          <a:noFill/>
+          <a:ln/>
+        </p:spPr>
+        <p:txBody>
+          <a:bodyPr wrap="square" lIns="0" tIns="0" rIns="0" bIns="0" rtlCol="0" anchor="ctr"/>
           <a:lstStyle/>
           <a:p>
             <a:pPr algn="ctr" indent="0" marL="0">
               <a:buNone/>
             </a:pPr>
             <a:r>
-              <a:rPr lang="en-US" sz="1500" b="1" dirty="0">
-                <a:solidFill>
-                  <a:srgbClr val="27272A"/>
+              <a:rPr lang="en-US" sz="2000" b="1" dirty="0">
+                <a:solidFill>
+                  <a:srgbClr val="FFFFFF"/>
                 </a:solidFill>
                 <a:latin typeface="Poppins" pitchFamily="34" charset="0"/>
                 <a:ea typeface="Poppins" pitchFamily="34" charset="-122"/>
                 <a:cs typeface="Poppins" pitchFamily="34" charset="-120"/>
               </a:rPr>
-              <a:t>Sin límite de tiempo</a:t>
-            </a:r>
-            <a:endParaRPr lang="en-US" sz="1500" dirty="0"/>
-          </a:p>
-        </p:txBody>
-      </p:sp>
-      <p:sp>
-        <p:nvSpPr>
-          <p:cNvPr id="12" name="Shape 7"/>
+              <a:t>B</a:t>
+            </a:r>
+            <a:endParaRPr lang="en-US" sz="2000" dirty="0"/>
+          </a:p>
+        </p:txBody>
+      </p:sp>
+      <p:sp>
+        <p:nvSpPr>
+          <p:cNvPr id="22" name="Text 17"/>
+          <p:cNvSpPr txBox="1"/>
+          <p:nvPr/>
+        </p:nvSpPr>
+        <p:spPr>
+          <a:xfrm>
+            <a:off x="4725314" y="3310128"/>
+            <a:ext cx="2741066" cy="548640"/>
+          </a:xfrm>
+          <a:prstGeom prst="rect">
+            <a:avLst/>
+          </a:prstGeom>
+          <a:noFill/>
+          <a:ln/>
+        </p:spPr>
+        <p:txBody>
+          <a:bodyPr wrap="square" lIns="0" tIns="0" rIns="0" bIns="0" rtlCol="0" anchor="t"/>
+          <a:lstStyle/>
+          <a:p>
+            <a:pPr indent="0" marL="0">
+              <a:lnSpc>
+                <a:spcPct val="115000"/>
+              </a:lnSpc>
+              <a:buNone/>
+            </a:pPr>
+            <a:r>
+              <a:rPr lang="en-US" sz="1650" b="1" dirty="0">
+                <a:solidFill>
+                  <a:srgbClr val="27272A"/>
+                </a:solidFill>
+                <a:latin typeface="Poppins" pitchFamily="34" charset="0"/>
+                <a:ea typeface="Poppins" pitchFamily="34" charset="-122"/>
+                <a:cs typeface="Poppins" pitchFamily="34" charset="-120"/>
+              </a:rPr>
+              <a:t>Ejecución</a:t>
+            </a:r>
+            <a:endParaRPr lang="en-US" sz="1650" dirty="0"/>
+          </a:p>
+        </p:txBody>
+      </p:sp>
+      <p:sp>
+        <p:nvSpPr>
+          <p:cNvPr id="23" name="Shape 18"/>
           <p:cNvSpPr/>
           <p:nvPr/>
         </p:nvSpPr>
         <p:spPr>
           <a:xfrm>
-            <a:off x="8121701" y="2331720"/>
-            <a:ext cx="3411626" cy="1371600"/>
+            <a:off x="4725314" y="4453128"/>
+            <a:ext cx="82296" cy="82296"/>
+          </a:xfrm>
+          <a:prstGeom prst="ellipse">
+            <a:avLst/>
+          </a:prstGeom>
+          <a:solidFill>
+            <a:srgbClr val="FF007C"/>
+          </a:solidFill>
+          <a:ln/>
+        </p:spPr>
+      </p:sp>
+      <p:sp>
+        <p:nvSpPr>
+          <p:cNvPr id="24" name="Text 19"/>
+          <p:cNvSpPr txBox="1"/>
+          <p:nvPr/>
+        </p:nvSpPr>
+        <p:spPr>
+          <a:xfrm>
+            <a:off x="4926482" y="4325112"/>
+            <a:ext cx="2539898" cy="457200"/>
+          </a:xfrm>
+          <a:prstGeom prst="rect">
+            <a:avLst/>
+          </a:prstGeom>
+          <a:noFill/>
+          <a:ln/>
+        </p:spPr>
+        <p:txBody>
+          <a:bodyPr wrap="square" lIns="0" tIns="0" rIns="0" bIns="0" rtlCol="0" anchor="t"/>
+          <a:lstStyle/>
+          <a:p>
+            <a:pPr indent="0" marL="0">
+              <a:lnSpc>
+                <a:spcPct val="120000"/>
+              </a:lnSpc>
+              <a:buNone/>
+            </a:pPr>
+            <a:r>
+              <a:rPr lang="en-US" sz="1250" dirty="0">
+                <a:solidFill>
+                  <a:srgbClr val="27272A"/>
+                </a:solidFill>
+                <a:latin typeface="Poppins" pitchFamily="34" charset="0"/>
+                <a:ea typeface="Poppins" pitchFamily="34" charset="-122"/>
+                <a:cs typeface="Poppins" pitchFamily="34" charset="-120"/>
+              </a:rPr>
+              <a:t>Landings automáticas</a:t>
+            </a:r>
+            <a:endParaRPr lang="en-US" sz="1250" dirty="0"/>
+          </a:p>
+        </p:txBody>
+      </p:sp>
+      <p:sp>
+        <p:nvSpPr>
+          <p:cNvPr id="25" name="Shape 20"/>
+          <p:cNvSpPr/>
+          <p:nvPr/>
+        </p:nvSpPr>
+        <p:spPr>
+          <a:xfrm>
+            <a:off x="4725314" y="4910328"/>
+            <a:ext cx="82296" cy="82296"/>
+          </a:xfrm>
+          <a:prstGeom prst="ellipse">
+            <a:avLst/>
+          </a:prstGeom>
+          <a:solidFill>
+            <a:srgbClr val="FF007C"/>
+          </a:solidFill>
+          <a:ln/>
+        </p:spPr>
+      </p:sp>
+      <p:sp>
+        <p:nvSpPr>
+          <p:cNvPr id="26" name="Text 21"/>
+          <p:cNvSpPr txBox="1"/>
+          <p:nvPr/>
+        </p:nvSpPr>
+        <p:spPr>
+          <a:xfrm>
+            <a:off x="4926482" y="4782312"/>
+            <a:ext cx="2539898" cy="457200"/>
+          </a:xfrm>
+          <a:prstGeom prst="rect">
+            <a:avLst/>
+          </a:prstGeom>
+          <a:noFill/>
+          <a:ln/>
+        </p:spPr>
+        <p:txBody>
+          <a:bodyPr wrap="square" lIns="0" tIns="0" rIns="0" bIns="0" rtlCol="0" anchor="t"/>
+          <a:lstStyle/>
+          <a:p>
+            <a:pPr indent="0" marL="0">
+              <a:lnSpc>
+                <a:spcPct val="120000"/>
+              </a:lnSpc>
+              <a:buNone/>
+            </a:pPr>
+            <a:r>
+              <a:rPr lang="en-US" sz="1250" dirty="0">
+                <a:solidFill>
+                  <a:srgbClr val="27272A"/>
+                </a:solidFill>
+                <a:latin typeface="Poppins" pitchFamily="34" charset="0"/>
+                <a:ea typeface="Poppins" pitchFamily="34" charset="-122"/>
+                <a:cs typeface="Poppins" pitchFamily="34" charset="-120"/>
+              </a:rPr>
+              <a:t>Automatizaciones de email</a:t>
+            </a:r>
+            <a:endParaRPr lang="en-US" sz="1250" dirty="0"/>
+          </a:p>
+        </p:txBody>
+      </p:sp>
+      <p:sp>
+        <p:nvSpPr>
+          <p:cNvPr id="27" name="Shape 22"/>
+          <p:cNvSpPr/>
+          <p:nvPr/>
+        </p:nvSpPr>
+        <p:spPr>
+          <a:xfrm>
+            <a:off x="4725314" y="5367528"/>
+            <a:ext cx="82296" cy="82296"/>
+          </a:xfrm>
+          <a:prstGeom prst="ellipse">
+            <a:avLst/>
+          </a:prstGeom>
+          <a:solidFill>
+            <a:srgbClr val="FF007C"/>
+          </a:solidFill>
+          <a:ln/>
+        </p:spPr>
+      </p:sp>
+      <p:sp>
+        <p:nvSpPr>
+          <p:cNvPr id="28" name="Text 23"/>
+          <p:cNvSpPr txBox="1"/>
+          <p:nvPr/>
+        </p:nvSpPr>
+        <p:spPr>
+          <a:xfrm>
+            <a:off x="4926482" y="5239512"/>
+            <a:ext cx="2539898" cy="457200"/>
+          </a:xfrm>
+          <a:prstGeom prst="rect">
+            <a:avLst/>
+          </a:prstGeom>
+          <a:noFill/>
+          <a:ln/>
+        </p:spPr>
+        <p:txBody>
+          <a:bodyPr wrap="square" lIns="0" tIns="0" rIns="0" bIns="0" rtlCol="0" anchor="t"/>
+          <a:lstStyle/>
+          <a:p>
+            <a:pPr indent="0" marL="0">
+              <a:lnSpc>
+                <a:spcPct val="120000"/>
+              </a:lnSpc>
+              <a:buNone/>
+            </a:pPr>
+            <a:r>
+              <a:rPr lang="en-US" sz="1250" dirty="0">
+                <a:solidFill>
+                  <a:srgbClr val="27272A"/>
+                </a:solidFill>
+                <a:latin typeface="Poppins" pitchFamily="34" charset="0"/>
+                <a:ea typeface="Poppins" pitchFamily="34" charset="-122"/>
+                <a:cs typeface="Poppins" pitchFamily="34" charset="-120"/>
+              </a:rPr>
+              <a:t>Asistente de IA</a:t>
+            </a:r>
+            <a:endParaRPr lang="en-US" sz="1250" dirty="0"/>
+          </a:p>
+        </p:txBody>
+      </p:sp>
+      <p:sp>
+        <p:nvSpPr>
+          <p:cNvPr id="29" name="Text 24"/>
+          <p:cNvSpPr txBox="1"/>
+          <p:nvPr/>
+        </p:nvSpPr>
+        <p:spPr>
+          <a:xfrm>
+            <a:off x="7740701" y="2542032"/>
+            <a:ext cx="502920" cy="566928"/>
+          </a:xfrm>
+          <a:prstGeom prst="rect">
+            <a:avLst/>
+          </a:prstGeom>
+          <a:noFill/>
+          <a:ln/>
+        </p:spPr>
+        <p:txBody>
+          <a:bodyPr wrap="square" lIns="0" tIns="0" rIns="0" bIns="0" rtlCol="0" anchor="ctr"/>
+          <a:lstStyle/>
+          <a:p>
+            <a:pPr algn="ctr" indent="0" marL="0">
+              <a:buNone/>
+            </a:pPr>
+            <a:r>
+              <a:rPr lang="en-US" sz="2200" b="1" dirty="0">
+                <a:solidFill>
+                  <a:srgbClr val="FF007C"/>
+                </a:solidFill>
+                <a:latin typeface="Poppins" pitchFamily="34" charset="0"/>
+                <a:ea typeface="Poppins" pitchFamily="34" charset="-122"/>
+                <a:cs typeface="Poppins" pitchFamily="34" charset="-120"/>
+              </a:rPr>
+              <a:t>→</a:t>
+            </a:r>
+            <a:endParaRPr lang="en-US" sz="2200" dirty="0"/>
+          </a:p>
+        </p:txBody>
+      </p:sp>
+      <p:sp>
+        <p:nvSpPr>
+          <p:cNvPr id="30" name="Shape 25"/>
+          <p:cNvSpPr/>
+          <p:nvPr/>
+        </p:nvSpPr>
+        <p:spPr>
+          <a:xfrm>
+            <a:off x="8243621" y="2286000"/>
+            <a:ext cx="3289706" cy="3840480"/>
           </a:xfrm>
           <a:prstGeom prst="roundRect">
             <a:avLst>
-              <a:gd name="adj" fmla="val 12000"/>
+              <a:gd name="adj" fmla="val 5003"/>
             </a:avLst>
           </a:prstGeom>
           <a:solidFill>
@@ -2923,7 +3627,7 @@
       </p:sp>
       <p:pic>
         <p:nvPicPr>
-          <p:cNvPr id="13" name="Image 3" descr="/tmp/claude-0/-home-claude/34a532c3-29f6-5221-b4ba-d8e6b49c9601/scratchpad/vendepro/assets/icon_check_grad.png">    </p:cNvPr>
+          <p:cNvPr id="31" name="Image 3" descr="/tmp/claude-0/-home-claude/34a532c3-29f6-5221-b4ba-d8e6b49c9601/scratchpad/vendepro/assets/grad_num_circle.png">    </p:cNvPr>
           <p:cNvPicPr>
             <a:picLocks noChangeAspect="1"/>
           </p:cNvPicPr>
@@ -2937,8 +3641,8 @@
         </p:blipFill>
         <p:spPr>
           <a:xfrm>
-            <a:off x="9598914" y="2624328"/>
-            <a:ext cx="457200" cy="457200"/>
+            <a:off x="8517941" y="2560320"/>
+            <a:ext cx="548640" cy="548640"/>
           </a:xfrm>
           <a:prstGeom prst="rect">
             <a:avLst/>
@@ -2947,53 +3651,53 @@
       </p:pic>
       <p:sp>
         <p:nvSpPr>
-          <p:cNvPr id="14" name="Text 8"/>
-          <p:cNvSpPr txBox="1"/>
-          <p:nvPr/>
-        </p:nvSpPr>
-        <p:spPr>
-          <a:xfrm>
-            <a:off x="8304581" y="3200400"/>
-            <a:ext cx="3045866" cy="457200"/>
-          </a:xfrm>
-          <a:prstGeom prst="rect">
-            <a:avLst/>
-          </a:prstGeom>
-          <a:noFill/>
-          <a:ln/>
-        </p:spPr>
-        <p:txBody>
-          <a:bodyPr wrap="square" lIns="0" tIns="0" rIns="0" bIns="0" rtlCol="0" anchor="t"/>
+          <p:cNvPr id="32" name="Text 26"/>
+          <p:cNvSpPr txBox="1"/>
+          <p:nvPr/>
+        </p:nvSpPr>
+        <p:spPr>
+          <a:xfrm>
+            <a:off x="8517941" y="2560320"/>
+            <a:ext cx="548640" cy="548640"/>
+          </a:xfrm>
+          <a:prstGeom prst="rect">
+            <a:avLst/>
+          </a:prstGeom>
+          <a:noFill/>
+          <a:ln/>
+        </p:spPr>
+        <p:txBody>
+          <a:bodyPr wrap="square" lIns="0" tIns="0" rIns="0" bIns="0" rtlCol="0" anchor="ctr"/>
           <a:lstStyle/>
           <a:p>
             <a:pPr algn="ctr" indent="0" marL="0">
               <a:buNone/>
             </a:pPr>
             <a:r>
-              <a:rPr lang="en-US" sz="1500" b="1" dirty="0">
-                <a:solidFill>
-                  <a:srgbClr val="27272A"/>
+              <a:rPr lang="en-US" sz="2000" b="1" dirty="0">
+                <a:solidFill>
+                  <a:srgbClr val="FFFFFF"/>
                 </a:solidFill>
                 <a:latin typeface="Poppins" pitchFamily="34" charset="0"/>
                 <a:ea typeface="Poppins" pitchFamily="34" charset="-122"/>
                 <a:cs typeface="Poppins" pitchFamily="34" charset="-120"/>
               </a:rPr>
-              <a:t>Setup en 2 minutos</a:t>
-            </a:r>
-            <a:endParaRPr lang="en-US" sz="1500" dirty="0"/>
-          </a:p>
-        </p:txBody>
-      </p:sp>
-      <p:sp>
-        <p:nvSpPr>
-          <p:cNvPr id="15" name="Text 9"/>
-          <p:cNvSpPr txBox="1"/>
-          <p:nvPr/>
-        </p:nvSpPr>
-        <p:spPr>
-          <a:xfrm>
-            <a:off x="658368" y="4160520"/>
-            <a:ext cx="10874959" cy="731520"/>
+              <a:t>C</a:t>
+            </a:r>
+            <a:endParaRPr lang="en-US" sz="2000" dirty="0"/>
+          </a:p>
+        </p:txBody>
+      </p:sp>
+      <p:sp>
+        <p:nvSpPr>
+          <p:cNvPr id="33" name="Text 27"/>
+          <p:cNvSpPr txBox="1"/>
+          <p:nvPr/>
+        </p:nvSpPr>
+        <p:spPr>
+          <a:xfrm>
+            <a:off x="8517941" y="3310128"/>
+            <a:ext cx="2741066" cy="548640"/>
           </a:xfrm>
           <a:prstGeom prst="rect">
             <a:avLst/>
@@ -3005,24 +3709,187 @@
           <a:bodyPr wrap="square" lIns="0" tIns="0" rIns="0" bIns="0" rtlCol="0" anchor="t"/>
           <a:lstStyle/>
           <a:p>
-            <a:pPr algn="l" indent="0" marL="0">
+            <a:pPr indent="0" marL="0">
               <a:lnSpc>
-                <a:spcPct val="130000"/>
+                <a:spcPct val="115000"/>
               </a:lnSpc>
               <a:buNone/>
             </a:pPr>
             <a:r>
-              <a:rPr lang="en-US" sz="1600" dirty="0">
-                <a:solidFill>
-                  <a:srgbClr val="52525B"/>
+              <a:rPr lang="en-US" sz="1650" b="1" dirty="0">
+                <a:solidFill>
+                  <a:srgbClr val="27272A"/>
+                </a:solidFill>
+                <a:latin typeface="Poppins" pitchFamily="34" charset="0"/>
+                <a:ea typeface="Poppins" pitchFamily="34" charset="-122"/>
+                <a:cs typeface="Poppins" pitchFamily="34" charset="-120"/>
+              </a:rPr>
+              <a:t>Ecosistema</a:t>
+            </a:r>
+            <a:endParaRPr lang="en-US" sz="1650" dirty="0"/>
+          </a:p>
+        </p:txBody>
+      </p:sp>
+      <p:sp>
+        <p:nvSpPr>
+          <p:cNvPr id="34" name="Text 28"/>
+          <p:cNvSpPr txBox="1"/>
+          <p:nvPr/>
+        </p:nvSpPr>
+        <p:spPr>
+          <a:xfrm>
+            <a:off x="8517941" y="3913632"/>
+            <a:ext cx="2741066" cy="320040"/>
+          </a:xfrm>
+          <a:prstGeom prst="rect">
+            <a:avLst/>
+          </a:prstGeom>
+          <a:noFill/>
+          <a:ln/>
+        </p:spPr>
+        <p:txBody>
+          <a:bodyPr wrap="square" lIns="0" tIns="0" rIns="0" bIns="0" rtlCol="0" anchor="t"/>
+          <a:lstStyle/>
+          <a:p>
+            <a:pPr indent="0" marL="0">
+              <a:buNone/>
+            </a:pPr>
+            <a:r>
+              <a:rPr lang="en-US" sz="1150" i="1" dirty="0">
+                <a:solidFill>
+                  <a:srgbClr val="71717A"/>
                 </a:solidFill>
                 <a:latin typeface="Poppins Medium" pitchFamily="34" charset="0"/>
                 <a:ea typeface="Poppins Medium" pitchFamily="34" charset="-122"/>
                 <a:cs typeface="Poppins Medium" pitchFamily="34" charset="-120"/>
               </a:rPr>
-              <a:t>El plan gratuito incluye las funciones principales. Probalo con tus próximos leads de esta semana.</a:t>
-            </a:r>
-            <a:endParaRPr lang="en-US" sz="1600" dirty="0"/>
+              <a:t>(largo plazo)</a:t>
+            </a:r>
+            <a:endParaRPr lang="en-US" sz="1150" dirty="0"/>
+          </a:p>
+        </p:txBody>
+      </p:sp>
+      <p:sp>
+        <p:nvSpPr>
+          <p:cNvPr id="35" name="Shape 29"/>
+          <p:cNvSpPr/>
+          <p:nvPr/>
+        </p:nvSpPr>
+        <p:spPr>
+          <a:xfrm>
+            <a:off x="8517941" y="4453128"/>
+            <a:ext cx="82296" cy="82296"/>
+          </a:xfrm>
+          <a:prstGeom prst="ellipse">
+            <a:avLst/>
+          </a:prstGeom>
+          <a:solidFill>
+            <a:srgbClr val="FF007C"/>
+          </a:solidFill>
+          <a:ln/>
+        </p:spPr>
+      </p:sp>
+      <p:sp>
+        <p:nvSpPr>
+          <p:cNvPr id="36" name="Text 30"/>
+          <p:cNvSpPr txBox="1"/>
+          <p:nvPr/>
+        </p:nvSpPr>
+        <p:spPr>
+          <a:xfrm>
+            <a:off x="8719109" y="4325112"/>
+            <a:ext cx="2539898" cy="457200"/>
+          </a:xfrm>
+          <a:prstGeom prst="rect">
+            <a:avLst/>
+          </a:prstGeom>
+          <a:noFill/>
+          <a:ln/>
+        </p:spPr>
+        <p:txBody>
+          <a:bodyPr wrap="square" lIns="0" tIns="0" rIns="0" bIns="0" rtlCol="0" anchor="t"/>
+          <a:lstStyle/>
+          <a:p>
+            <a:pPr indent="0" marL="0">
+              <a:lnSpc>
+                <a:spcPct val="120000"/>
+              </a:lnSpc>
+              <a:buNone/>
+            </a:pPr>
+            <a:r>
+              <a:rPr lang="en-US" sz="1250" dirty="0">
+                <a:solidFill>
+                  <a:srgbClr val="27272A"/>
+                </a:solidFill>
+                <a:latin typeface="Poppins" pitchFamily="34" charset="0"/>
+                <a:ea typeface="Poppins" pitchFamily="34" charset="-122"/>
+                <a:cs typeface="Poppins" pitchFamily="34" charset="-120"/>
+              </a:rPr>
+              <a:t>Marketplace de proveedores</a:t>
+            </a:r>
+            <a:endParaRPr lang="en-US" sz="1250" dirty="0"/>
+          </a:p>
+        </p:txBody>
+      </p:sp>
+      <p:sp>
+        <p:nvSpPr>
+          <p:cNvPr id="37" name="Shape 31"/>
+          <p:cNvSpPr/>
+          <p:nvPr/>
+        </p:nvSpPr>
+        <p:spPr>
+          <a:xfrm>
+            <a:off x="8517941" y="4910328"/>
+            <a:ext cx="82296" cy="82296"/>
+          </a:xfrm>
+          <a:prstGeom prst="ellipse">
+            <a:avLst/>
+          </a:prstGeom>
+          <a:solidFill>
+            <a:srgbClr val="FF007C"/>
+          </a:solidFill>
+          <a:ln/>
+        </p:spPr>
+      </p:sp>
+      <p:sp>
+        <p:nvSpPr>
+          <p:cNvPr id="38" name="Text 32"/>
+          <p:cNvSpPr txBox="1"/>
+          <p:nvPr/>
+        </p:nvSpPr>
+        <p:spPr>
+          <a:xfrm>
+            <a:off x="8719109" y="4782312"/>
+            <a:ext cx="2539898" cy="457200"/>
+          </a:xfrm>
+          <a:prstGeom prst="rect">
+            <a:avLst/>
+          </a:prstGeom>
+          <a:noFill/>
+          <a:ln/>
+        </p:spPr>
+        <p:txBody>
+          <a:bodyPr wrap="square" lIns="0" tIns="0" rIns="0" bIns="0" rtlCol="0" anchor="t"/>
+          <a:lstStyle/>
+          <a:p>
+            <a:pPr indent="0" marL="0">
+              <a:lnSpc>
+                <a:spcPct val="120000"/>
+              </a:lnSpc>
+              <a:buNone/>
+            </a:pPr>
+            <a:r>
+              <a:rPr lang="en-US" sz="1250" dirty="0">
+                <a:solidFill>
+                  <a:srgbClr val="27272A"/>
+                </a:solidFill>
+                <a:latin typeface="Poppins" pitchFamily="34" charset="0"/>
+                <a:ea typeface="Poppins" pitchFamily="34" charset="-122"/>
+                <a:cs typeface="Poppins" pitchFamily="34" charset="-120"/>
+              </a:rPr>
+              <a:t>Academia</a:t>
+            </a:r>
+            <a:endParaRPr lang="en-US" sz="1250" dirty="0"/>
           </a:p>
         </p:txBody>
       </p:sp>
@@ -3037,6 +3904,500 @@
 <file path=ppt/slides/slide12.xml><?xml version="1.0" encoding="utf-8"?>
 <p:sld xmlns:a="http://schemas.openxmlformats.org/drawingml/2006/main" xmlns:r="http://schemas.openxmlformats.org/officeDocument/2006/relationships" xmlns:p="http://schemas.openxmlformats.org/presentationml/2006/main">
   <p:cSld name="Slide 12">
+    <p:bg>
+      <p:bgPr>
+        <a:solidFill>
+          <a:srgbClr val="FFFFFF"/>
+        </a:solidFill>
+      </p:bgPr>
+    </p:bg>
+    <p:spTree>
+      <p:nvGrpSpPr>
+        <p:cNvPr id="1" name=""/>
+        <p:cNvGrpSpPr/>
+        <p:nvPr/>
+      </p:nvGrpSpPr>
+      <p:grpSpPr>
+        <a:xfrm>
+          <a:off x="0" y="0"/>
+          <a:ext cx="0" cy="0"/>
+          <a:chOff x="0" y="0"/>
+          <a:chExt cx="0" cy="0"/>
+        </a:xfrm>
+      </p:grpSpPr>
+      <p:pic>
+        <p:nvPicPr>
+          <p:cNvPr id="2" name="Image 0" descr="/tmp/claude-0/-home-claude/34a532c3-29f6-5221-b4ba-d8e6b49c9601/scratchpad/vendepro/assets/grad_tab_vertical.png">    </p:cNvPr>
+          <p:cNvPicPr>
+            <a:picLocks noChangeAspect="1"/>
+          </p:cNvPicPr>
+          <p:nvPr/>
+        </p:nvPicPr>
+        <p:blipFill>
+          <a:blip r:embed="rId1"/>
+          <a:stretch>
+            <a:fillRect/>
+          </a:stretch>
+        </p:blipFill>
+        <p:spPr>
+          <a:xfrm>
+            <a:off x="658368" y="612648"/>
+            <a:ext cx="82296" cy="457200"/>
+          </a:xfrm>
+          <a:prstGeom prst="rect">
+            <a:avLst/>
+          </a:prstGeom>
+        </p:spPr>
+      </p:pic>
+      <p:sp>
+        <p:nvSpPr>
+          <p:cNvPr id="3" name="Text 0"/>
+          <p:cNvSpPr txBox="1"/>
+          <p:nvPr/>
+        </p:nvSpPr>
+        <p:spPr>
+          <a:xfrm>
+            <a:off x="896112" y="512064"/>
+            <a:ext cx="10369296" cy="1051560"/>
+          </a:xfrm>
+          <a:prstGeom prst="rect">
+            <a:avLst/>
+          </a:prstGeom>
+          <a:noFill/>
+          <a:ln/>
+        </p:spPr>
+        <p:txBody>
+          <a:bodyPr wrap="square" lIns="0" tIns="0" rIns="0" bIns="0" rtlCol="0" anchor="t"/>
+          <a:lstStyle/>
+          <a:p>
+            <a:pPr algn="l" indent="0" marL="0">
+              <a:lnSpc>
+                <a:spcPct val="108000"/>
+              </a:lnSpc>
+              <a:buNone/>
+            </a:pPr>
+            <a:r>
+              <a:rPr lang="en-US" sz="2800" b="1" dirty="0">
+                <a:solidFill>
+                  <a:srgbClr val="27272A"/>
+                </a:solidFill>
+                <a:latin typeface="Poppins" pitchFamily="34" charset="0"/>
+                <a:ea typeface="Poppins" pitchFamily="34" charset="-122"/>
+                <a:cs typeface="Poppins" pitchFamily="34" charset="-120"/>
+              </a:rPr>
+              <a:t>Sin tarjeta. Sin límite de tiempo. Setup en 2 minutos.</a:t>
+            </a:r>
+            <a:endParaRPr lang="en-US" sz="2800" dirty="0"/>
+          </a:p>
+        </p:txBody>
+      </p:sp>
+      <p:sp>
+        <p:nvSpPr>
+          <p:cNvPr id="4" name="Text 1"/>
+          <p:cNvSpPr txBox="1"/>
+          <p:nvPr/>
+        </p:nvSpPr>
+        <p:spPr>
+          <a:xfrm>
+            <a:off x="658368" y="6437376"/>
+            <a:ext cx="1828800" cy="274320"/>
+          </a:xfrm>
+          <a:prstGeom prst="rect">
+            <a:avLst/>
+          </a:prstGeom>
+          <a:noFill/>
+          <a:ln/>
+        </p:spPr>
+        <p:txBody>
+          <a:bodyPr wrap="square" lIns="0" tIns="0" rIns="0" bIns="0" rtlCol="0" anchor="ctr"/>
+          <a:lstStyle/>
+          <a:p>
+            <a:pPr algn="l" indent="0" marL="0">
+              <a:buNone/>
+            </a:pPr>
+            <a:r>
+              <a:rPr lang="en-US" sz="950" spc="100" kern="0" dirty="0">
+                <a:solidFill>
+                  <a:srgbClr val="A1A1AA"/>
+                </a:solidFill>
+                <a:latin typeface="Poppins Medium" pitchFamily="34" charset="0"/>
+                <a:ea typeface="Poppins Medium" pitchFamily="34" charset="-122"/>
+                <a:cs typeface="Poppins Medium" pitchFamily="34" charset="-120"/>
+              </a:rPr>
+              <a:t>VendéPro</a:t>
+            </a:r>
+            <a:endParaRPr lang="en-US" sz="950" dirty="0"/>
+          </a:p>
+        </p:txBody>
+      </p:sp>
+      <p:sp>
+        <p:nvSpPr>
+          <p:cNvPr id="5" name="Text 2"/>
+          <p:cNvSpPr txBox="1"/>
+          <p:nvPr/>
+        </p:nvSpPr>
+        <p:spPr>
+          <a:xfrm>
+            <a:off x="10436047" y="6437376"/>
+            <a:ext cx="1097280" cy="274320"/>
+          </a:xfrm>
+          <a:prstGeom prst="rect">
+            <a:avLst/>
+          </a:prstGeom>
+          <a:noFill/>
+          <a:ln/>
+        </p:spPr>
+        <p:txBody>
+          <a:bodyPr wrap="square" lIns="0" tIns="0" rIns="0" bIns="0" rtlCol="0" anchor="ctr"/>
+          <a:lstStyle/>
+          <a:p>
+            <a:pPr algn="r" indent="0" marL="0">
+              <a:buNone/>
+            </a:pPr>
+            <a:r>
+              <a:rPr lang="en-US" sz="950" dirty="0">
+                <a:solidFill>
+                  <a:srgbClr val="A1A1AA"/>
+                </a:solidFill>
+                <a:latin typeface="Poppins Medium" pitchFamily="34" charset="0"/>
+                <a:ea typeface="Poppins Medium" pitchFamily="34" charset="-122"/>
+                <a:cs typeface="Poppins Medium" pitchFamily="34" charset="-120"/>
+              </a:rPr>
+              <a:t>12 / 13</a:t>
+            </a:r>
+            <a:endParaRPr lang="en-US" sz="950" dirty="0"/>
+          </a:p>
+        </p:txBody>
+      </p:sp>
+      <p:sp>
+        <p:nvSpPr>
+          <p:cNvPr id="6" name="Shape 3"/>
+          <p:cNvSpPr/>
+          <p:nvPr/>
+        </p:nvSpPr>
+        <p:spPr>
+          <a:xfrm>
+            <a:off x="658368" y="2331720"/>
+            <a:ext cx="3411626" cy="1371600"/>
+          </a:xfrm>
+          <a:prstGeom prst="roundRect">
+            <a:avLst>
+              <a:gd name="adj" fmla="val 12000"/>
+            </a:avLst>
+          </a:prstGeom>
+          <a:solidFill>
+            <a:srgbClr val="F6F6F7"/>
+          </a:solidFill>
+          <a:ln/>
+          <a:effectLst>
+            <a:outerShdw sx="100000" sy="100000" kx="0" ky="0" algn="bl" rotWithShape="0" blurRad="127000" dist="38100" dir="5400000">
+              <a:srgbClr val="27272A">
+                <a:alpha val="12000"/>
+              </a:srgbClr>
+            </a:outerShdw>
+          </a:effectLst>
+        </p:spPr>
+      </p:sp>
+      <p:pic>
+        <p:nvPicPr>
+          <p:cNvPr id="7" name="Image 1" descr="/tmp/claude-0/-home-claude/34a532c3-29f6-5221-b4ba-d8e6b49c9601/scratchpad/vendepro/assets/icon_check_grad.png">    </p:cNvPr>
+          <p:cNvPicPr>
+            <a:picLocks noChangeAspect="1"/>
+          </p:cNvPicPr>
+          <p:nvPr/>
+        </p:nvPicPr>
+        <p:blipFill>
+          <a:blip r:embed="rId2"/>
+          <a:stretch>
+            <a:fillRect/>
+          </a:stretch>
+        </p:blipFill>
+        <p:spPr>
+          <a:xfrm>
+            <a:off x="2135581" y="2624328"/>
+            <a:ext cx="457200" cy="457200"/>
+          </a:xfrm>
+          <a:prstGeom prst="rect">
+            <a:avLst/>
+          </a:prstGeom>
+        </p:spPr>
+      </p:pic>
+      <p:sp>
+        <p:nvSpPr>
+          <p:cNvPr id="8" name="Text 4"/>
+          <p:cNvSpPr txBox="1"/>
+          <p:nvPr/>
+        </p:nvSpPr>
+        <p:spPr>
+          <a:xfrm>
+            <a:off x="841248" y="3200400"/>
+            <a:ext cx="3045866" cy="457200"/>
+          </a:xfrm>
+          <a:prstGeom prst="rect">
+            <a:avLst/>
+          </a:prstGeom>
+          <a:noFill/>
+          <a:ln/>
+        </p:spPr>
+        <p:txBody>
+          <a:bodyPr wrap="square" lIns="0" tIns="0" rIns="0" bIns="0" rtlCol="0" anchor="t"/>
+          <a:lstStyle/>
+          <a:p>
+            <a:pPr algn="ctr" indent="0" marL="0">
+              <a:buNone/>
+            </a:pPr>
+            <a:r>
+              <a:rPr lang="en-US" sz="1500" b="1" dirty="0">
+                <a:solidFill>
+                  <a:srgbClr val="27272A"/>
+                </a:solidFill>
+                <a:latin typeface="Poppins" pitchFamily="34" charset="0"/>
+                <a:ea typeface="Poppins" pitchFamily="34" charset="-122"/>
+                <a:cs typeface="Poppins" pitchFamily="34" charset="-120"/>
+              </a:rPr>
+              <a:t>Sin tarjeta</a:t>
+            </a:r>
+            <a:endParaRPr lang="en-US" sz="1500" dirty="0"/>
+          </a:p>
+        </p:txBody>
+      </p:sp>
+      <p:sp>
+        <p:nvSpPr>
+          <p:cNvPr id="9" name="Shape 5"/>
+          <p:cNvSpPr/>
+          <p:nvPr/>
+        </p:nvSpPr>
+        <p:spPr>
+          <a:xfrm>
+            <a:off x="4390034" y="2331720"/>
+            <a:ext cx="3411626" cy="1371600"/>
+          </a:xfrm>
+          <a:prstGeom prst="roundRect">
+            <a:avLst>
+              <a:gd name="adj" fmla="val 12000"/>
+            </a:avLst>
+          </a:prstGeom>
+          <a:solidFill>
+            <a:srgbClr val="F6F6F7"/>
+          </a:solidFill>
+          <a:ln/>
+          <a:effectLst>
+            <a:outerShdw sx="100000" sy="100000" kx="0" ky="0" algn="bl" rotWithShape="0" blurRad="127000" dist="38100" dir="5400000">
+              <a:srgbClr val="27272A">
+                <a:alpha val="12000"/>
+              </a:srgbClr>
+            </a:outerShdw>
+          </a:effectLst>
+        </p:spPr>
+      </p:sp>
+      <p:pic>
+        <p:nvPicPr>
+          <p:cNvPr id="10" name="Image 2" descr="/tmp/claude-0/-home-claude/34a532c3-29f6-5221-b4ba-d8e6b49c9601/scratchpad/vendepro/assets/icon_check_grad.png">    </p:cNvPr>
+          <p:cNvPicPr>
+            <a:picLocks noChangeAspect="1"/>
+          </p:cNvPicPr>
+          <p:nvPr/>
+        </p:nvPicPr>
+        <p:blipFill>
+          <a:blip r:embed="rId3"/>
+          <a:stretch>
+            <a:fillRect/>
+          </a:stretch>
+        </p:blipFill>
+        <p:spPr>
+          <a:xfrm>
+            <a:off x="5867248" y="2624328"/>
+            <a:ext cx="457200" cy="457200"/>
+          </a:xfrm>
+          <a:prstGeom prst="rect">
+            <a:avLst/>
+          </a:prstGeom>
+        </p:spPr>
+      </p:pic>
+      <p:sp>
+        <p:nvSpPr>
+          <p:cNvPr id="11" name="Text 6"/>
+          <p:cNvSpPr txBox="1"/>
+          <p:nvPr/>
+        </p:nvSpPr>
+        <p:spPr>
+          <a:xfrm>
+            <a:off x="4572914" y="3200400"/>
+            <a:ext cx="3045866" cy="457200"/>
+          </a:xfrm>
+          <a:prstGeom prst="rect">
+            <a:avLst/>
+          </a:prstGeom>
+          <a:noFill/>
+          <a:ln/>
+        </p:spPr>
+        <p:txBody>
+          <a:bodyPr wrap="square" lIns="0" tIns="0" rIns="0" bIns="0" rtlCol="0" anchor="t"/>
+          <a:lstStyle/>
+          <a:p>
+            <a:pPr algn="ctr" indent="0" marL="0">
+              <a:buNone/>
+            </a:pPr>
+            <a:r>
+              <a:rPr lang="en-US" sz="1500" b="1" dirty="0">
+                <a:solidFill>
+                  <a:srgbClr val="27272A"/>
+                </a:solidFill>
+                <a:latin typeface="Poppins" pitchFamily="34" charset="0"/>
+                <a:ea typeface="Poppins" pitchFamily="34" charset="-122"/>
+                <a:cs typeface="Poppins" pitchFamily="34" charset="-120"/>
+              </a:rPr>
+              <a:t>Sin límite de tiempo</a:t>
+            </a:r>
+            <a:endParaRPr lang="en-US" sz="1500" dirty="0"/>
+          </a:p>
+        </p:txBody>
+      </p:sp>
+      <p:sp>
+        <p:nvSpPr>
+          <p:cNvPr id="12" name="Shape 7"/>
+          <p:cNvSpPr/>
+          <p:nvPr/>
+        </p:nvSpPr>
+        <p:spPr>
+          <a:xfrm>
+            <a:off x="8121701" y="2331720"/>
+            <a:ext cx="3411626" cy="1371600"/>
+          </a:xfrm>
+          <a:prstGeom prst="roundRect">
+            <a:avLst>
+              <a:gd name="adj" fmla="val 12000"/>
+            </a:avLst>
+          </a:prstGeom>
+          <a:solidFill>
+            <a:srgbClr val="F6F6F7"/>
+          </a:solidFill>
+          <a:ln/>
+          <a:effectLst>
+            <a:outerShdw sx="100000" sy="100000" kx="0" ky="0" algn="bl" rotWithShape="0" blurRad="127000" dist="38100" dir="5400000">
+              <a:srgbClr val="27272A">
+                <a:alpha val="12000"/>
+              </a:srgbClr>
+            </a:outerShdw>
+          </a:effectLst>
+        </p:spPr>
+      </p:sp>
+      <p:pic>
+        <p:nvPicPr>
+          <p:cNvPr id="13" name="Image 3" descr="/tmp/claude-0/-home-claude/34a532c3-29f6-5221-b4ba-d8e6b49c9601/scratchpad/vendepro/assets/icon_check_grad.png">    </p:cNvPr>
+          <p:cNvPicPr>
+            <a:picLocks noChangeAspect="1"/>
+          </p:cNvPicPr>
+          <p:nvPr/>
+        </p:nvPicPr>
+        <p:blipFill>
+          <a:blip r:embed="rId4"/>
+          <a:stretch>
+            <a:fillRect/>
+          </a:stretch>
+        </p:blipFill>
+        <p:spPr>
+          <a:xfrm>
+            <a:off x="9598914" y="2624328"/>
+            <a:ext cx="457200" cy="457200"/>
+          </a:xfrm>
+          <a:prstGeom prst="rect">
+            <a:avLst/>
+          </a:prstGeom>
+        </p:spPr>
+      </p:pic>
+      <p:sp>
+        <p:nvSpPr>
+          <p:cNvPr id="14" name="Text 8"/>
+          <p:cNvSpPr txBox="1"/>
+          <p:nvPr/>
+        </p:nvSpPr>
+        <p:spPr>
+          <a:xfrm>
+            <a:off x="8304581" y="3200400"/>
+            <a:ext cx="3045866" cy="457200"/>
+          </a:xfrm>
+          <a:prstGeom prst="rect">
+            <a:avLst/>
+          </a:prstGeom>
+          <a:noFill/>
+          <a:ln/>
+        </p:spPr>
+        <p:txBody>
+          <a:bodyPr wrap="square" lIns="0" tIns="0" rIns="0" bIns="0" rtlCol="0" anchor="t"/>
+          <a:lstStyle/>
+          <a:p>
+            <a:pPr algn="ctr" indent="0" marL="0">
+              <a:buNone/>
+            </a:pPr>
+            <a:r>
+              <a:rPr lang="en-US" sz="1500" b="1" dirty="0">
+                <a:solidFill>
+                  <a:srgbClr val="27272A"/>
+                </a:solidFill>
+                <a:latin typeface="Poppins" pitchFamily="34" charset="0"/>
+                <a:ea typeface="Poppins" pitchFamily="34" charset="-122"/>
+                <a:cs typeface="Poppins" pitchFamily="34" charset="-120"/>
+              </a:rPr>
+              <a:t>Setup en 2 minutos</a:t>
+            </a:r>
+            <a:endParaRPr lang="en-US" sz="1500" dirty="0"/>
+          </a:p>
+        </p:txBody>
+      </p:sp>
+      <p:sp>
+        <p:nvSpPr>
+          <p:cNvPr id="15" name="Text 9"/>
+          <p:cNvSpPr txBox="1"/>
+          <p:nvPr/>
+        </p:nvSpPr>
+        <p:spPr>
+          <a:xfrm>
+            <a:off x="658368" y="4160520"/>
+            <a:ext cx="10874959" cy="731520"/>
+          </a:xfrm>
+          <a:prstGeom prst="rect">
+            <a:avLst/>
+          </a:prstGeom>
+          <a:noFill/>
+          <a:ln/>
+        </p:spPr>
+        <p:txBody>
+          <a:bodyPr wrap="square" lIns="0" tIns="0" rIns="0" bIns="0" rtlCol="0" anchor="t"/>
+          <a:lstStyle/>
+          <a:p>
+            <a:pPr algn="l" indent="0" marL="0">
+              <a:lnSpc>
+                <a:spcPct val="130000"/>
+              </a:lnSpc>
+              <a:buNone/>
+            </a:pPr>
+            <a:r>
+              <a:rPr lang="en-US" sz="1600" dirty="0">
+                <a:solidFill>
+                  <a:srgbClr val="52525B"/>
+                </a:solidFill>
+                <a:latin typeface="Poppins Medium" pitchFamily="34" charset="0"/>
+                <a:ea typeface="Poppins Medium" pitchFamily="34" charset="-122"/>
+                <a:cs typeface="Poppins Medium" pitchFamily="34" charset="-120"/>
+              </a:rPr>
+              <a:t>El plan gratuito incluye las funciones principales. Probalo con tus próximos leads de esta semana.</a:t>
+            </a:r>
+            <a:endParaRPr lang="en-US" sz="1600" dirty="0"/>
+          </a:p>
+        </p:txBody>
+      </p:sp>
+    </p:spTree>
+  </p:cSld>
+  <p:clrMapOvr>
+    <a:masterClrMapping/>
+  </p:clrMapOvr>
+</p:sld>
+</file>
+
+<file path=ppt/slides/slide13.xml><?xml version="1.0" encoding="utf-8"?>
+<p:sld xmlns:a="http://schemas.openxmlformats.org/drawingml/2006/main" xmlns:r="http://schemas.openxmlformats.org/officeDocument/2006/relationships" xmlns:p="http://schemas.openxmlformats.org/presentationml/2006/main">
+  <p:cSld name="Slide 13">
     <p:bg>
       <p:bgPr>
         <a:solidFill>
@@ -3278,7 +4639,7 @@
                 <a:ea typeface="Poppins Medium" pitchFamily="34" charset="-122"/>
                 <a:cs typeface="Poppins Medium" pitchFamily="34" charset="-120"/>
               </a:rPr>
-              <a:t>12 / 12</a:t>
+              <a:t>13 / 13</a:t>
             </a:r>
             <a:endParaRPr lang="en-US" sz="950" dirty="0"/>
           </a:p>
@@ -3454,7 +4815,7 @@
                 <a:ea typeface="Poppins Medium" pitchFamily="34" charset="-122"/>
                 <a:cs typeface="Poppins Medium" pitchFamily="34" charset="-120"/>
               </a:rPr>
-              <a:t>02 / 12</a:t>
+              <a:t>02 / 13</a:t>
             </a:r>
             <a:endParaRPr lang="en-US" sz="950" dirty="0"/>
           </a:p>
@@ -4010,7 +5371,7 @@
                 <a:ea typeface="Poppins Medium" pitchFamily="34" charset="-122"/>
                 <a:cs typeface="Poppins Medium" pitchFamily="34" charset="-120"/>
               </a:rPr>
-              <a:t>03 / 12</a:t>
+              <a:t>03 / 13</a:t>
             </a:r>
             <a:endParaRPr lang="en-US" sz="950" dirty="0"/>
           </a:p>
@@ -4553,7 +5914,7 @@
                 <a:ea typeface="Poppins Medium" pitchFamily="34" charset="-122"/>
                 <a:cs typeface="Poppins Medium" pitchFamily="34" charset="-120"/>
               </a:rPr>
-              <a:t>04 / 12</a:t>
+              <a:t>04 / 13</a:t>
             </a:r>
             <a:endParaRPr lang="en-US" sz="950" dirty="0"/>
           </a:p>
@@ -4729,7 +6090,7 @@
                 <a:ea typeface="Poppins Medium" pitchFamily="34" charset="-122"/>
                 <a:cs typeface="Poppins Medium" pitchFamily="34" charset="-120"/>
               </a:rPr>
-              <a:t>05 / 12</a:t>
+              <a:t>05 / 13</a:t>
             </a:r>
             <a:endParaRPr lang="en-US" sz="950" dirty="0"/>
           </a:p>
@@ -5285,7 +6646,7 @@
                 <a:ea typeface="Poppins Medium" pitchFamily="34" charset="-122"/>
                 <a:cs typeface="Poppins Medium" pitchFamily="34" charset="-120"/>
               </a:rPr>
-              <a:t>06 / 12</a:t>
+              <a:t>06 / 13</a:t>
             </a:r>
             <a:endParaRPr lang="en-US" sz="950" dirty="0"/>
           </a:p>
@@ -5875,7 +7236,7 @@
                 <a:ea typeface="Poppins Medium" pitchFamily="34" charset="-122"/>
                 <a:cs typeface="Poppins Medium" pitchFamily="34" charset="-120"/>
               </a:rPr>
-              <a:t>07 / 12</a:t>
+              <a:t>07 / 13</a:t>
             </a:r>
             <a:endParaRPr lang="en-US" sz="950" dirty="0"/>
           </a:p>
@@ -6583,7 +7944,7 @@
                 <a:ea typeface="Poppins Medium" pitchFamily="34" charset="-122"/>
                 <a:cs typeface="Poppins Medium" pitchFamily="34" charset="-120"/>
               </a:rPr>
-              <a:t>08 / 12</a:t>
+              <a:t>08 / 13</a:t>
             </a:r>
             <a:endParaRPr lang="en-US" sz="950" dirty="0"/>
           </a:p>
@@ -7062,7 +8423,7 @@
                 <a:ea typeface="Poppins Medium" pitchFamily="34" charset="-122"/>
                 <a:cs typeface="Poppins Medium" pitchFamily="34" charset="-120"/>
               </a:rPr>
-              <a:t>09 / 12</a:t>
+              <a:t>09 / 13</a:t>
             </a:r>
             <a:endParaRPr lang="en-US" sz="950" dirty="0"/>
           </a:p>

</xml_diff>